<commit_message>
Se actualiza presentacion y se sube planilla fase 1
</commit_message>
<xml_diff>
--- a/Fase 1/Evidencias Grupales/Presentación Proyecto.pptx
+++ b/Fase 1/Evidencias Grupales/Presentación Proyecto.pptx
@@ -1334,7 +1334,7 @@
         <p:spPr>
           <a:xfrm>
             <a:off x="428625" y="1951360"/>
-            <a:ext cx="8286750" cy="1351508"/>
+            <a:ext cx="8286750" cy="1205266"/>
           </a:xfrm>
           <a:prstGeom prst="rect">
             <a:avLst/>
@@ -1363,7 +1363,7 @@
                 <a:ea typeface="Inter Bold" pitchFamily="34" charset="-122"/>
                 <a:cs typeface="Inter Bold" pitchFamily="34" charset="-120"/>
               </a:rPr>
-              <a:t>PROYECTO
+              <a:t>PROYECTO DE CAPSTONE
 “DISCOVER”</a:t>
             </a:r>
             <a:endParaRPr lang="en-US" sz="4450" dirty="0"/>
@@ -1379,7 +1379,7 @@
         <p:spPr>
           <a:xfrm>
             <a:off x="428625" y="3445743"/>
-            <a:ext cx="8286750" cy="275034"/>
+            <a:ext cx="8286750" cy="261610"/>
           </a:xfrm>
           <a:prstGeom prst="rect">
             <a:avLst/>
@@ -1396,17 +1396,6 @@
             <a:pPr marL="0" indent="0" algn="l">
               <a:buNone/>
             </a:pPr>
-            <a:r>
-              <a:rPr lang="en-US" sz="1700" kern="0" spc="3" dirty="0">
-                <a:solidFill>
-                  <a:srgbClr val="8B9DAA"/>
-                </a:solidFill>
-                <a:latin typeface="Inter" pitchFamily="34" charset="0"/>
-                <a:ea typeface="Inter" pitchFamily="34" charset="-122"/>
-                <a:cs typeface="Inter" pitchFamily="34" charset="-120"/>
-              </a:rPr>
-              <a:t>PRESENTACIÓN FINAL</a:t>
-            </a:r>
             <a:endParaRPr lang="en-US" sz="1700" dirty="0"/>
           </a:p>
         </p:txBody>
@@ -1579,6 +1568,67 @@
           </a:prstGeom>
         </p:spPr>
       </p:pic>
+      <p:sp>
+        <p:nvSpPr>
+          <p:cNvPr id="9" name="Text 9">
+            <a:extLst>
+              <a:ext uri="{FF2B5EF4-FFF2-40B4-BE49-F238E27FC236}">
+                <a16:creationId xmlns:a16="http://schemas.microsoft.com/office/drawing/2014/main" id="{A036083F-9122-6C61-3521-3B13B77D80DF}"/>
+              </a:ext>
+            </a:extLst>
+          </p:cNvPr>
+          <p:cNvSpPr/>
+          <p:nvPr/>
+        </p:nvSpPr>
+        <p:spPr>
+          <a:xfrm>
+            <a:off x="513533" y="4058022"/>
+            <a:ext cx="3687570" cy="189604"/>
+          </a:xfrm>
+          <a:prstGeom prst="rect">
+            <a:avLst/>
+          </a:prstGeom>
+          <a:noFill/>
+          <a:ln/>
+        </p:spPr>
+        <p:txBody>
+          <a:bodyPr wrap="square" lIns="0" tIns="0" rIns="0" bIns="0" rtlCol="0" anchor="t">
+            <a:spAutoFit/>
+          </a:bodyPr>
+          <a:lstStyle/>
+          <a:p>
+            <a:pPr marL="0" indent="0" algn="l">
+              <a:lnSpc>
+                <a:spcPct val="120000"/>
+              </a:lnSpc>
+              <a:buNone/>
+            </a:pPr>
+            <a:r>
+              <a:rPr lang="en-US" sz="1100" dirty="0">
+                <a:solidFill>
+                  <a:srgbClr val="8B9DAA"/>
+                </a:solidFill>
+                <a:latin typeface="Inter" pitchFamily="34" charset="0"/>
+                <a:ea typeface="Inter" pitchFamily="34" charset="-122"/>
+                <a:cs typeface="Inter" pitchFamily="34" charset="-120"/>
+              </a:rPr>
+              <a:t>Docente</a:t>
+            </a:r>
+            <a:r>
+              <a:rPr lang="en-US" sz="950" dirty="0">
+                <a:solidFill>
+                  <a:srgbClr val="8B9DAA"/>
+                </a:solidFill>
+                <a:latin typeface="Inter" pitchFamily="34" charset="0"/>
+                <a:ea typeface="Inter" pitchFamily="34" charset="-122"/>
+                <a:cs typeface="Inter" pitchFamily="34" charset="-120"/>
+              </a:rPr>
+              <a:t>: Felix Eduardo Cifuentes CID</a:t>
+            </a:r>
+            <a:endParaRPr lang="en-US" sz="950" dirty="0"/>
+          </a:p>
+        </p:txBody>
+      </p:sp>
     </p:spTree>
   </p:cSld>
   <p:clrMapOvr>
@@ -2914,7 +2964,7 @@
         <p:spPr>
           <a:xfrm>
             <a:off x="428625" y="1378744"/>
-            <a:ext cx="3857625" cy="969496"/>
+            <a:ext cx="3857625" cy="807913"/>
           </a:xfrm>
           <a:prstGeom prst="rect">
             <a:avLst/>
@@ -2934,7 +2984,7 @@
                   <a:schemeClr val="bg1"/>
                 </a:solidFill>
               </a:rPr>
-              <a:t>Actualmente, encontrar y descubrir contenido, lugares, servicios o experiencias que sean realmente relevantes para cada usuario puede resultar difícil cuando la información se encuentra distribuida en diferentes plataformas y fuentes. Esto puede generar una experiencia poco personalizada y dificultar que los usuarios encuentren nuevas alternativas de acuerdo con sus intereses y necesidades.</a:t>
+              <a:t>Actualmente, encontrar y descubrir contenido que sea interesante para cada usuario puede resultar difícil cuando la información se encuentra distribuida en diferentes plataformas y fuentes. Esto puede generar una experiencia dispersa y dificultar que los usuarios encuentren nuevas alternativas.</a:t>
             </a:r>
             <a:endParaRPr lang="en-US" sz="1050" dirty="0">
               <a:solidFill>
@@ -2994,7 +3044,7 @@
         <p:spPr>
           <a:xfrm>
             <a:off x="428625" y="3053953"/>
-            <a:ext cx="3857625" cy="1077218"/>
+            <a:ext cx="3857625" cy="923330"/>
           </a:xfrm>
           <a:prstGeom prst="rect">
             <a:avLst/>
@@ -3022,7 +3072,7 @@
                   <a:schemeClr val="bg1"/>
                 </a:solidFill>
               </a:rPr>
-              <a:t> propone una plataforma web de descubrimiento que centraliza información y facilita a los usuarios la exploración de diferentes alternativas de acuerdo con sus intereses. La solución busca entregar una experiencia de usuario simple e intuitiva, incorporando tecnologías como </a:t>
+              <a:t> propone una plataforma web de recomendaciones que centraliza contenidos y facilita a los usuarios la exploración de diferentes alternativas. La solución busca entregar una experiencia de usuario simple e intuitiva, incorporando tecnologías como </a:t>
             </a:r>
             <a:r>
               <a:rPr lang="es-CL" sz="1000" b="1" dirty="0">
@@ -3038,7 +3088,7 @@
                   <a:schemeClr val="bg1"/>
                 </a:solidFill>
               </a:rPr>
-              <a:t>, permitiendo gestionar, integrar y presentar información de manera organizada y facilitar el proceso de descubrimiento.</a:t>
+              <a:t>, permitiendo gestionar, compartir y explorar información de manera llamativa y facilitar el proceso de descubrimiento.</a:t>
             </a:r>
             <a:endParaRPr lang="en-US" sz="1000" dirty="0">
               <a:solidFill>
@@ -3662,7 +3712,29 @@
                 <a:ea typeface="Inter" pitchFamily="34" charset="-122"/>
                 <a:cs typeface="Inter" pitchFamily="34" charset="-120"/>
               </a:rPr>
-              <a:t>Diseñar e implementar una API REST escalable utilizando Django REST Framework para la comunicación de servicios.</a:t>
+              <a:t>Diseñar e implementar una API REST escalable </a:t>
+            </a:r>
+            <a:r>
+              <a:rPr lang="en-US" sz="950" dirty="0" err="1">
+                <a:solidFill>
+                  <a:srgbClr val="8B9DAA"/>
+                </a:solidFill>
+                <a:latin typeface="Inter" pitchFamily="34" charset="0"/>
+                <a:ea typeface="Inter" pitchFamily="34" charset="-122"/>
+                <a:cs typeface="Inter" pitchFamily="34" charset="-120"/>
+              </a:rPr>
+              <a:t>utilizando</a:t>
+            </a:r>
+            <a:r>
+              <a:rPr lang="en-US" sz="950" dirty="0">
+                <a:solidFill>
+                  <a:srgbClr val="8B9DAA"/>
+                </a:solidFill>
+                <a:latin typeface="Inter" pitchFamily="34" charset="0"/>
+                <a:ea typeface="Inter" pitchFamily="34" charset="-122"/>
+                <a:cs typeface="Inter" pitchFamily="34" charset="-120"/>
+              </a:rPr>
+              <a:t> Django REST Framework para la comunicación de servicios.</a:t>
             </a:r>
             <a:endParaRPr lang="en-US" sz="950" dirty="0"/>
           </a:p>
@@ -3803,7 +3875,7 @@
         <p:spPr>
           <a:xfrm>
             <a:off x="777273" y="3695328"/>
-            <a:ext cx="3687570" cy="578644"/>
+            <a:ext cx="3687570" cy="339132"/>
           </a:xfrm>
           <a:prstGeom prst="rect">
             <a:avLst/>
@@ -3832,7 +3904,73 @@
                 <a:ea typeface="Inter" pitchFamily="34" charset="-122"/>
                 <a:cs typeface="Inter" pitchFamily="34" charset="-120"/>
               </a:rPr>
-              <a:t>Integrar modelos de Inteligencia Artificial para el procesamiento y análisis avanzado de la información técnica.</a:t>
+              <a:t>Integrar modelos de Inteligencia Artificial para el procesamiento y </a:t>
+            </a:r>
+            <a:r>
+              <a:rPr lang="en-US" sz="950" dirty="0" err="1">
+                <a:solidFill>
+                  <a:srgbClr val="8B9DAA"/>
+                </a:solidFill>
+                <a:latin typeface="Inter" pitchFamily="34" charset="0"/>
+                <a:ea typeface="Inter" pitchFamily="34" charset="-122"/>
+                <a:cs typeface="Inter" pitchFamily="34" charset="-120"/>
+              </a:rPr>
+              <a:t>creación</a:t>
+            </a:r>
+            <a:r>
+              <a:rPr lang="en-US" sz="950" dirty="0">
+                <a:solidFill>
+                  <a:srgbClr val="8B9DAA"/>
+                </a:solidFill>
+                <a:latin typeface="Inter" pitchFamily="34" charset="0"/>
+                <a:ea typeface="Inter" pitchFamily="34" charset="-122"/>
+                <a:cs typeface="Inter" pitchFamily="34" charset="-120"/>
+              </a:rPr>
+              <a:t>  de la </a:t>
+            </a:r>
+            <a:r>
+              <a:rPr lang="en-US" sz="950" dirty="0" err="1">
+                <a:solidFill>
+                  <a:srgbClr val="8B9DAA"/>
+                </a:solidFill>
+                <a:latin typeface="Inter" pitchFamily="34" charset="0"/>
+                <a:ea typeface="Inter" pitchFamily="34" charset="-122"/>
+                <a:cs typeface="Inter" pitchFamily="34" charset="-120"/>
+              </a:rPr>
+              <a:t>información</a:t>
+            </a:r>
+            <a:r>
+              <a:rPr lang="en-US" sz="950" dirty="0">
+                <a:solidFill>
+                  <a:srgbClr val="8B9DAA"/>
+                </a:solidFill>
+                <a:latin typeface="Inter" pitchFamily="34" charset="0"/>
+                <a:ea typeface="Inter" pitchFamily="34" charset="-122"/>
+                <a:cs typeface="Inter" pitchFamily="34" charset="-120"/>
+              </a:rPr>
+              <a:t> del </a:t>
+            </a:r>
+            <a:r>
+              <a:rPr lang="en-US" sz="950" dirty="0" err="1">
+                <a:solidFill>
+                  <a:srgbClr val="8B9DAA"/>
+                </a:solidFill>
+                <a:latin typeface="Inter" pitchFamily="34" charset="0"/>
+                <a:ea typeface="Inter" pitchFamily="34" charset="-122"/>
+                <a:cs typeface="Inter" pitchFamily="34" charset="-120"/>
+              </a:rPr>
+              <a:t>contenido</a:t>
+            </a:r>
+            <a:r>
+              <a:rPr lang="en-US" sz="950" dirty="0">
+                <a:solidFill>
+                  <a:srgbClr val="8B9DAA"/>
+                </a:solidFill>
+                <a:latin typeface="Inter" pitchFamily="34" charset="0"/>
+                <a:ea typeface="Inter" pitchFamily="34" charset="-122"/>
+                <a:cs typeface="Inter" pitchFamily="34" charset="-120"/>
+              </a:rPr>
+              <a:t>.</a:t>
             </a:r>
             <a:endParaRPr lang="en-US" sz="950" dirty="0"/>
           </a:p>
@@ -4328,7 +4466,7 @@
         <p:spPr>
           <a:xfrm>
             <a:off x="571500" y="1768078"/>
-            <a:ext cx="3561159" cy="350044"/>
+            <a:ext cx="3561159" cy="163699"/>
           </a:xfrm>
           <a:prstGeom prst="rect">
             <a:avLst/>
@@ -4357,7 +4495,7 @@
                 <a:ea typeface="Inter" pitchFamily="34" charset="-122"/>
                 <a:cs typeface="Inter" pitchFamily="34" charset="-120"/>
               </a:rPr>
-              <a:t>Desarrollo de una API REST funcional para la gestión de datos técnicos.</a:t>
+              <a:t>    Desarrollo de una API REST funcional para la gestión de datos técnicos.</a:t>
             </a:r>
             <a:endParaRPr lang="en-US" sz="950" dirty="0"/>
           </a:p>
@@ -4401,7 +4539,29 @@
                 <a:ea typeface="Inter" pitchFamily="34" charset="-122"/>
                 <a:cs typeface="Inter" pitchFamily="34" charset="-120"/>
               </a:rPr>
-              <a:t>Tiempo de desarrollo limitado a 4 meses y 2 semanas según calendario académico.</a:t>
+              <a:t>   </a:t>
+            </a:r>
+            <a:r>
+              <a:rPr lang="en-US" sz="950" dirty="0" err="1">
+                <a:solidFill>
+                  <a:srgbClr val="F5F5F0"/>
+                </a:solidFill>
+                <a:latin typeface="Inter" pitchFamily="34" charset="0"/>
+                <a:ea typeface="Inter" pitchFamily="34" charset="-122"/>
+                <a:cs typeface="Inter" pitchFamily="34" charset="-120"/>
+              </a:rPr>
+              <a:t>Tiempo</a:t>
+            </a:r>
+            <a:r>
+              <a:rPr lang="en-US" sz="950" dirty="0">
+                <a:solidFill>
+                  <a:srgbClr val="F5F5F0"/>
+                </a:solidFill>
+                <a:latin typeface="Inter" pitchFamily="34" charset="0"/>
+                <a:ea typeface="Inter" pitchFamily="34" charset="-122"/>
+                <a:cs typeface="Inter" pitchFamily="34" charset="-120"/>
+              </a:rPr>
+              <a:t> de desarrollo limitado a 4 meses y 2 semanas según calendario académico.</a:t>
             </a:r>
             <a:endParaRPr lang="en-US" sz="950" dirty="0"/>
           </a:p>
@@ -4445,7 +4605,29 @@
                 <a:ea typeface="Inter" pitchFamily="34" charset="-122"/>
                 <a:cs typeface="Inter" pitchFamily="34" charset="-120"/>
               </a:rPr>
-              <a:t>Implementación de una base de datos MySQL normalizada y segura.</a:t>
+              <a:t>    </a:t>
+            </a:r>
+            <a:r>
+              <a:rPr lang="en-US" sz="950" dirty="0" err="1">
+                <a:solidFill>
+                  <a:srgbClr val="F5F5F0"/>
+                </a:solidFill>
+                <a:latin typeface="Inter" pitchFamily="34" charset="0"/>
+                <a:ea typeface="Inter" pitchFamily="34" charset="-122"/>
+                <a:cs typeface="Inter" pitchFamily="34" charset="-120"/>
+              </a:rPr>
+              <a:t>Implementación</a:t>
+            </a:r>
+            <a:r>
+              <a:rPr lang="en-US" sz="950" dirty="0">
+                <a:solidFill>
+                  <a:srgbClr val="F5F5F0"/>
+                </a:solidFill>
+                <a:latin typeface="Inter" pitchFamily="34" charset="0"/>
+                <a:ea typeface="Inter" pitchFamily="34" charset="-122"/>
+                <a:cs typeface="Inter" pitchFamily="34" charset="-120"/>
+              </a:rPr>
+              <a:t> de una base de datos MySQL normalizada y segura.</a:t>
             </a:r>
             <a:endParaRPr lang="en-US" sz="950" dirty="0"/>
           </a:p>
@@ -4489,7 +4671,7 @@
                 <a:ea typeface="Inter" pitchFamily="34" charset="-122"/>
                 <a:cs typeface="Inter" pitchFamily="34" charset="-120"/>
               </a:rPr>
-              <a:t>Disponibilidad de testers externos limitada para </a:t>
+              <a:t>   </a:t>
             </a:r>
             <a:r>
               <a:rPr lang="en-US" sz="950" dirty="0" err="1">
@@ -4500,6 +4682,28 @@
                 <a:ea typeface="Inter" pitchFamily="34" charset="-122"/>
                 <a:cs typeface="Inter" pitchFamily="34" charset="-120"/>
               </a:rPr>
+              <a:t>Disponibilidad</a:t>
+            </a:r>
+            <a:r>
+              <a:rPr lang="en-US" sz="950" dirty="0">
+                <a:solidFill>
+                  <a:srgbClr val="F5F5F0"/>
+                </a:solidFill>
+                <a:latin typeface="Inter" pitchFamily="34" charset="0"/>
+                <a:ea typeface="Inter" pitchFamily="34" charset="-122"/>
+                <a:cs typeface="Inter" pitchFamily="34" charset="-120"/>
+              </a:rPr>
+              <a:t> de testers externos limitada para </a:t>
+            </a:r>
+            <a:r>
+              <a:rPr lang="en-US" sz="950" dirty="0" err="1">
+                <a:solidFill>
+                  <a:srgbClr val="F5F5F0"/>
+                </a:solidFill>
+                <a:latin typeface="Inter" pitchFamily="34" charset="0"/>
+                <a:ea typeface="Inter" pitchFamily="34" charset="-122"/>
+                <a:cs typeface="Inter" pitchFamily="34" charset="-120"/>
+              </a:rPr>
               <a:t>pruebas</a:t>
             </a:r>
             <a:r>
@@ -4526,7 +4730,7 @@
         <p:spPr>
           <a:xfrm>
             <a:off x="571500" y="3268266"/>
-            <a:ext cx="2964656" cy="350044"/>
+            <a:ext cx="2964656" cy="339132"/>
           </a:xfrm>
           <a:prstGeom prst="rect">
             <a:avLst/>
@@ -4555,7 +4759,117 @@
                 <a:ea typeface="Inter" pitchFamily="34" charset="-122"/>
                 <a:cs typeface="Inter" pitchFamily="34" charset="-120"/>
               </a:rPr>
-              <a:t>Integración de servicios de IA para análisis de información.</a:t>
+              <a:t>   </a:t>
+            </a:r>
+            <a:r>
+              <a:rPr lang="en-US" sz="950" dirty="0" err="1">
+                <a:solidFill>
+                  <a:srgbClr val="F5F5F0"/>
+                </a:solidFill>
+                <a:latin typeface="Inter" pitchFamily="34" charset="0"/>
+                <a:ea typeface="Inter" pitchFamily="34" charset="-122"/>
+                <a:cs typeface="Inter" pitchFamily="34" charset="-120"/>
+              </a:rPr>
+              <a:t>Integración</a:t>
+            </a:r>
+            <a:r>
+              <a:rPr lang="en-US" sz="950" dirty="0">
+                <a:solidFill>
+                  <a:srgbClr val="F5F5F0"/>
+                </a:solidFill>
+                <a:latin typeface="Inter" pitchFamily="34" charset="0"/>
+                <a:ea typeface="Inter" pitchFamily="34" charset="-122"/>
+                <a:cs typeface="Inter" pitchFamily="34" charset="-120"/>
+              </a:rPr>
+              <a:t> de servicios de IA con un MCP para </a:t>
+            </a:r>
+            <a:r>
+              <a:rPr lang="en-US" sz="950" dirty="0" err="1">
+                <a:solidFill>
+                  <a:srgbClr val="F5F5F0"/>
+                </a:solidFill>
+                <a:latin typeface="Inter" pitchFamily="34" charset="0"/>
+                <a:ea typeface="Inter" pitchFamily="34" charset="-122"/>
+                <a:cs typeface="Inter" pitchFamily="34" charset="-120"/>
+              </a:rPr>
+              <a:t>análisis</a:t>
+            </a:r>
+            <a:r>
+              <a:rPr lang="en-US" sz="950" dirty="0">
+                <a:solidFill>
+                  <a:srgbClr val="F5F5F0"/>
+                </a:solidFill>
+                <a:latin typeface="Inter" pitchFamily="34" charset="0"/>
+                <a:ea typeface="Inter" pitchFamily="34" charset="-122"/>
+                <a:cs typeface="Inter" pitchFamily="34" charset="-120"/>
+              </a:rPr>
+              <a:t> y </a:t>
+            </a:r>
+            <a:r>
+              <a:rPr lang="en-US" sz="950" dirty="0" err="1">
+                <a:solidFill>
+                  <a:srgbClr val="F5F5F0"/>
+                </a:solidFill>
+                <a:latin typeface="Inter" pitchFamily="34" charset="0"/>
+                <a:ea typeface="Inter" pitchFamily="34" charset="-122"/>
+                <a:cs typeface="Inter" pitchFamily="34" charset="-120"/>
+              </a:rPr>
+              <a:t>creación</a:t>
+            </a:r>
+            <a:r>
+              <a:rPr lang="en-US" sz="950" dirty="0">
+                <a:solidFill>
+                  <a:srgbClr val="F5F5F0"/>
+                </a:solidFill>
+                <a:latin typeface="Inter" pitchFamily="34" charset="0"/>
+                <a:ea typeface="Inter" pitchFamily="34" charset="-122"/>
+                <a:cs typeface="Inter" pitchFamily="34" charset="-120"/>
+              </a:rPr>
+              <a:t> de </a:t>
+            </a:r>
+            <a:r>
+              <a:rPr lang="en-US" sz="950" dirty="0" err="1">
+                <a:solidFill>
+                  <a:srgbClr val="F5F5F0"/>
+                </a:solidFill>
+                <a:latin typeface="Inter" pitchFamily="34" charset="0"/>
+                <a:ea typeface="Inter" pitchFamily="34" charset="-122"/>
+                <a:cs typeface="Inter" pitchFamily="34" charset="-120"/>
+              </a:rPr>
+              <a:t>información</a:t>
+            </a:r>
+            <a:r>
+              <a:rPr lang="en-US" sz="950" dirty="0">
+                <a:solidFill>
+                  <a:srgbClr val="F5F5F0"/>
+                </a:solidFill>
+                <a:latin typeface="Inter" pitchFamily="34" charset="0"/>
+                <a:ea typeface="Inter" pitchFamily="34" charset="-122"/>
+                <a:cs typeface="Inter" pitchFamily="34" charset="-120"/>
+              </a:rPr>
+              <a:t> de </a:t>
+            </a:r>
+            <a:r>
+              <a:rPr lang="en-US" sz="950" dirty="0" err="1">
+                <a:solidFill>
+                  <a:srgbClr val="F5F5F0"/>
+                </a:solidFill>
+                <a:latin typeface="Inter" pitchFamily="34" charset="0"/>
+                <a:ea typeface="Inter" pitchFamily="34" charset="-122"/>
+                <a:cs typeface="Inter" pitchFamily="34" charset="-120"/>
+              </a:rPr>
+              <a:t>textos</a:t>
+            </a:r>
+            <a:r>
+              <a:rPr lang="en-US" sz="950" dirty="0">
+                <a:solidFill>
+                  <a:srgbClr val="F5F5F0"/>
+                </a:solidFill>
+                <a:latin typeface="Inter" pitchFamily="34" charset="0"/>
+                <a:ea typeface="Inter" pitchFamily="34" charset="-122"/>
+                <a:cs typeface="Inter" pitchFamily="34" charset="-120"/>
+              </a:rPr>
+              <a:t>.</a:t>
             </a:r>
             <a:endParaRPr lang="en-US" sz="950" dirty="0"/>
           </a:p>
@@ -4570,7 +4884,7 @@
         <p:spPr>
           <a:xfrm>
             <a:off x="4441515" y="3268266"/>
-            <a:ext cx="3850481" cy="350044"/>
+            <a:ext cx="3850481" cy="163699"/>
           </a:xfrm>
           <a:prstGeom prst="rect">
             <a:avLst/>
@@ -4599,7 +4913,73 @@
                 <a:ea typeface="Inter" pitchFamily="34" charset="-122"/>
                 <a:cs typeface="Inter" pitchFamily="34" charset="-120"/>
               </a:rPr>
-              <a:t>Recursos de hardware limitados a equipos personales de los desarrolladores.</a:t>
+              <a:t>   </a:t>
+            </a:r>
+            <a:r>
+              <a:rPr lang="en-US" sz="950" dirty="0" err="1">
+                <a:solidFill>
+                  <a:srgbClr val="F5F5F0"/>
+                </a:solidFill>
+                <a:latin typeface="Inter" pitchFamily="34" charset="0"/>
+                <a:ea typeface="Inter" pitchFamily="34" charset="-122"/>
+                <a:cs typeface="Inter" pitchFamily="34" charset="-120"/>
+              </a:rPr>
+              <a:t>Recursos</a:t>
+            </a:r>
+            <a:r>
+              <a:rPr lang="en-US" sz="950" dirty="0">
+                <a:solidFill>
+                  <a:srgbClr val="F5F5F0"/>
+                </a:solidFill>
+                <a:latin typeface="Inter" pitchFamily="34" charset="0"/>
+                <a:ea typeface="Inter" pitchFamily="34" charset="-122"/>
+                <a:cs typeface="Inter" pitchFamily="34" charset="-120"/>
+              </a:rPr>
+              <a:t> de hardware limitados a equipos personales de </a:t>
+            </a:r>
+            <a:r>
+              <a:rPr lang="en-US" sz="950" dirty="0" err="1">
+                <a:solidFill>
+                  <a:srgbClr val="F5F5F0"/>
+                </a:solidFill>
+                <a:latin typeface="Inter" pitchFamily="34" charset="0"/>
+                <a:ea typeface="Inter" pitchFamily="34" charset="-122"/>
+                <a:cs typeface="Inter" pitchFamily="34" charset="-120"/>
+              </a:rPr>
+              <a:t>los</a:t>
+            </a:r>
+            <a:r>
+              <a:rPr lang="en-US" sz="950" dirty="0">
+                <a:solidFill>
+                  <a:srgbClr val="F5F5F0"/>
+                </a:solidFill>
+                <a:latin typeface="Inter" pitchFamily="34" charset="0"/>
+                <a:ea typeface="Inter" pitchFamily="34" charset="-122"/>
+                <a:cs typeface="Inter" pitchFamily="34" charset="-120"/>
+              </a:rPr>
+              <a:t> </a:t>
+            </a:r>
+            <a:r>
+              <a:rPr lang="en-US" sz="950" dirty="0" err="1">
+                <a:solidFill>
+                  <a:srgbClr val="F5F5F0"/>
+                </a:solidFill>
+                <a:latin typeface="Inter" pitchFamily="34" charset="0"/>
+                <a:ea typeface="Inter" pitchFamily="34" charset="-122"/>
+                <a:cs typeface="Inter" pitchFamily="34" charset="-120"/>
+              </a:rPr>
+              <a:t>desarrolladores</a:t>
+            </a:r>
+            <a:r>
+              <a:rPr lang="en-US" sz="950" dirty="0">
+                <a:solidFill>
+                  <a:srgbClr val="F5F5F0"/>
+                </a:solidFill>
+                <a:latin typeface="Inter" pitchFamily="34" charset="0"/>
+                <a:ea typeface="Inter" pitchFamily="34" charset="-122"/>
+                <a:cs typeface="Inter" pitchFamily="34" charset="-120"/>
+              </a:rPr>
+              <a:t>.</a:t>
             </a:r>
             <a:endParaRPr lang="en-US" sz="950" dirty="0"/>
           </a:p>
@@ -4614,7 +4994,7 @@
         <p:spPr>
           <a:xfrm>
             <a:off x="571500" y="4018359"/>
-            <a:ext cx="3078956" cy="350044"/>
+            <a:ext cx="3078956" cy="163699"/>
           </a:xfrm>
           <a:prstGeom prst="rect">
             <a:avLst/>
@@ -4643,7 +5023,29 @@
                 <a:ea typeface="Inter" pitchFamily="34" charset="-122"/>
                 <a:cs typeface="Inter" pitchFamily="34" charset="-120"/>
               </a:rPr>
-              <a:t>Interfaz web responsiva para la visualización de resultados.</a:t>
+              <a:t>   </a:t>
+            </a:r>
+            <a:r>
+              <a:rPr lang="en-US" sz="950" dirty="0" err="1">
+                <a:solidFill>
+                  <a:srgbClr val="F5F5F0"/>
+                </a:solidFill>
+                <a:latin typeface="Inter" pitchFamily="34" charset="0"/>
+                <a:ea typeface="Inter" pitchFamily="34" charset="-122"/>
+                <a:cs typeface="Inter" pitchFamily="34" charset="-120"/>
+              </a:rPr>
+              <a:t>Interfaz</a:t>
+            </a:r>
+            <a:r>
+              <a:rPr lang="en-US" sz="950" dirty="0">
+                <a:solidFill>
+                  <a:srgbClr val="F5F5F0"/>
+                </a:solidFill>
+                <a:latin typeface="Inter" pitchFamily="34" charset="0"/>
+                <a:ea typeface="Inter" pitchFamily="34" charset="-122"/>
+                <a:cs typeface="Inter" pitchFamily="34" charset="-120"/>
+              </a:rPr>
+              <a:t> web responsiva para la visualización de resultados.</a:t>
             </a:r>
             <a:endParaRPr lang="en-US" sz="950" dirty="0"/>
           </a:p>
@@ -4658,7 +5060,7 @@
         <p:spPr>
           <a:xfrm>
             <a:off x="4441515" y="4018359"/>
-            <a:ext cx="3986213" cy="350044"/>
+            <a:ext cx="3986213" cy="163699"/>
           </a:xfrm>
           <a:prstGeom prst="rect">
             <a:avLst/>
@@ -4687,7 +5089,29 @@
                 <a:ea typeface="Inter" pitchFamily="34" charset="-122"/>
                 <a:cs typeface="Inter" pitchFamily="34" charset="-120"/>
               </a:rPr>
-              <a:t>Dependencia de la estabilidad de APIs externas de Inteligencia Artificial.</a:t>
+              <a:t>   </a:t>
+            </a:r>
+            <a:r>
+              <a:rPr lang="en-US" sz="950" dirty="0" err="1">
+                <a:solidFill>
+                  <a:srgbClr val="F5F5F0"/>
+                </a:solidFill>
+                <a:latin typeface="Inter" pitchFamily="34" charset="0"/>
+                <a:ea typeface="Inter" pitchFamily="34" charset="-122"/>
+                <a:cs typeface="Inter" pitchFamily="34" charset="-120"/>
+              </a:rPr>
+              <a:t>Dependencia</a:t>
+            </a:r>
+            <a:r>
+              <a:rPr lang="en-US" sz="950" dirty="0">
+                <a:solidFill>
+                  <a:srgbClr val="F5F5F0"/>
+                </a:solidFill>
+                <a:latin typeface="Inter" pitchFamily="34" charset="0"/>
+                <a:ea typeface="Inter" pitchFamily="34" charset="-122"/>
+                <a:cs typeface="Inter" pitchFamily="34" charset="-120"/>
+              </a:rPr>
+              <a:t> de la estabilidad de APIs externas de Inteligencia Artificial.</a:t>
             </a:r>
             <a:endParaRPr lang="en-US" sz="950" dirty="0"/>
           </a:p>
@@ -4975,7 +5399,7 @@
         <p:spPr>
           <a:xfrm>
             <a:off x="428625" y="428625"/>
-            <a:ext cx="8286750" cy="275034"/>
+            <a:ext cx="8286750" cy="246221"/>
           </a:xfrm>
           <a:prstGeom prst="rect">
             <a:avLst/>
@@ -5001,7 +5425,7 @@
                 <a:ea typeface="Inter Bold" pitchFamily="34" charset="-122"/>
                 <a:cs typeface="Inter Bold" pitchFamily="34" charset="-120"/>
               </a:rPr>
-              <a:t>METODOLOGÍA DE TRABAJO</a:t>
+              <a:t>METODOLOGÍA DE TRABAJO SCRUM</a:t>
             </a:r>
             <a:endParaRPr lang="en-US" sz="1600" dirty="0"/>
           </a:p>
@@ -6352,8 +6776,8 @@
         </p:nvSpPr>
         <p:spPr>
           <a:xfrm>
-            <a:off x="1571625" y="2320826"/>
-            <a:ext cx="3571875" cy="285750"/>
+            <a:off x="3287519" y="2320826"/>
+            <a:ext cx="3492104" cy="285750"/>
           </a:xfrm>
           <a:prstGeom prst="rect">
             <a:avLst/>
@@ -6379,8 +6803,8 @@
         </p:nvSpPr>
         <p:spPr>
           <a:xfrm>
-            <a:off x="1571625" y="2320826"/>
-            <a:ext cx="3571875" cy="285750"/>
+            <a:off x="3287519" y="2320826"/>
+            <a:ext cx="1855981" cy="107722"/>
           </a:xfrm>
           <a:prstGeom prst="rect">
             <a:avLst/>
@@ -6406,7 +6830,7 @@
                 <a:ea typeface="Inter Bold" pitchFamily="34" charset="-122"/>
                 <a:cs typeface="Inter Bold" pitchFamily="34" charset="-120"/>
               </a:rPr>
-              <a:t>DESARROLLO E INTEGRACIÓN</a:t>
+              <a:t>DESARROLLO</a:t>
             </a:r>
             <a:endParaRPr lang="en-US" sz="700" dirty="0"/>
           </a:p>
@@ -6488,8 +6912,8 @@
         </p:nvSpPr>
         <p:spPr>
           <a:xfrm>
-            <a:off x="1571625" y="3208437"/>
-            <a:ext cx="1785938" cy="285750"/>
+            <a:off x="6779623" y="3208437"/>
+            <a:ext cx="1935751" cy="285750"/>
           </a:xfrm>
           <a:prstGeom prst="rect">
             <a:avLst/>
@@ -6515,8 +6939,8 @@
         </p:nvSpPr>
         <p:spPr>
           <a:xfrm>
-            <a:off x="1571625" y="3208437"/>
-            <a:ext cx="1785938" cy="285750"/>
+            <a:off x="6779623" y="3208436"/>
+            <a:ext cx="1935583" cy="107722"/>
           </a:xfrm>
           <a:prstGeom prst="rect">
             <a:avLst/>

</xml_diff>